<commit_message>
continuing the work on Luftfahrttechnik
</commit_message>
<xml_diff>
--- a/B.Sc. LRT/Luftfahrttechnik/images/LFT-Images.pptx
+++ b/B.Sc. LRT/Luftfahrttechnik/images/LFT-Images.pptx
@@ -5,11 +5,12 @@
     <p:sldMasterId id="2147483660" r:id="rId1"/>
   </p:sldMasterIdLst>
   <p:notesMasterIdLst>
-    <p:notesMasterId r:id="rId4"/>
+    <p:notesMasterId r:id="rId5"/>
   </p:notesMasterIdLst>
   <p:sldIdLst>
     <p:sldId id="256" r:id="rId2"/>
     <p:sldId id="257" r:id="rId3"/>
+    <p:sldId id="258" r:id="rId4"/>
   </p:sldIdLst>
   <p:sldSz cx="3600450" cy="3600450"/>
   <p:notesSz cx="6858000" cy="9144000"/>
@@ -11689,6 +11690,772 @@
     <p:extLst>
       <p:ext uri="{BB962C8B-B14F-4D97-AF65-F5344CB8AC3E}">
         <p14:creationId xmlns:p14="http://schemas.microsoft.com/office/powerpoint/2010/main" val="925403280"/>
+      </p:ext>
+    </p:extLst>
+  </p:cSld>
+  <p:clrMapOvr>
+    <a:masterClrMapping/>
+  </p:clrMapOvr>
+</p:sld>
+</file>
+
+<file path=ppt/slides/slide3.xml><?xml version="1.0" encoding="utf-8"?>
+<p:sld xmlns:a="http://schemas.openxmlformats.org/drawingml/2006/main" xmlns:r="http://schemas.openxmlformats.org/officeDocument/2006/relationships" xmlns:p="http://schemas.openxmlformats.org/presentationml/2006/main">
+  <p:cSld>
+    <p:spTree>
+      <p:nvGrpSpPr>
+        <p:cNvPr id="1" name=""/>
+        <p:cNvGrpSpPr/>
+        <p:nvPr/>
+      </p:nvGrpSpPr>
+      <p:grpSpPr>
+        <a:xfrm>
+          <a:off x="0" y="0"/>
+          <a:ext cx="0" cy="0"/>
+          <a:chOff x="0" y="0"/>
+          <a:chExt cx="0" cy="0"/>
+        </a:xfrm>
+      </p:grpSpPr>
+      <p:cxnSp>
+        <p:nvCxnSpPr>
+          <p:cNvPr id="13" name="Gerader Verbinder 12">
+            <a:extLst>
+              <a:ext uri="{FF2B5EF4-FFF2-40B4-BE49-F238E27FC236}">
+                <a16:creationId xmlns:a16="http://schemas.microsoft.com/office/drawing/2014/main" id="{4DCE6737-D821-330A-8D79-3B40B201CD72}"/>
+              </a:ext>
+            </a:extLst>
+          </p:cNvPr>
+          <p:cNvCxnSpPr>
+            <a:cxnSpLocks/>
+          </p:cNvCxnSpPr>
+          <p:nvPr/>
+        </p:nvCxnSpPr>
+        <p:spPr>
+          <a:xfrm flipV="1">
+            <a:off x="888435" y="1464496"/>
+            <a:ext cx="1618857" cy="1093945"/>
+          </a:xfrm>
+          <a:prstGeom prst="line">
+            <a:avLst/>
+          </a:prstGeom>
+          <a:ln w="12700" cap="rnd">
+            <a:prstDash val="sysDash"/>
+            <a:round/>
+          </a:ln>
+        </p:spPr>
+        <p:style>
+          <a:lnRef idx="2">
+            <a:schemeClr val="accent1"/>
+          </a:lnRef>
+          <a:fillRef idx="0">
+            <a:schemeClr val="accent1"/>
+          </a:fillRef>
+          <a:effectRef idx="1">
+            <a:schemeClr val="accent1"/>
+          </a:effectRef>
+          <a:fontRef idx="minor">
+            <a:schemeClr val="tx1"/>
+          </a:fontRef>
+        </p:style>
+      </p:cxnSp>
+      <p:cxnSp>
+        <p:nvCxnSpPr>
+          <p:cNvPr id="12" name="Gerader Verbinder 11">
+            <a:extLst>
+              <a:ext uri="{FF2B5EF4-FFF2-40B4-BE49-F238E27FC236}">
+                <a16:creationId xmlns:a16="http://schemas.microsoft.com/office/drawing/2014/main" id="{21EA963A-B307-98D3-98FE-91FEAD4BE2C3}"/>
+              </a:ext>
+            </a:extLst>
+          </p:cNvPr>
+          <p:cNvCxnSpPr/>
+          <p:nvPr/>
+        </p:nvCxnSpPr>
+        <p:spPr>
+          <a:xfrm>
+            <a:off x="888435" y="2007296"/>
+            <a:ext cx="1701321" cy="0"/>
+          </a:xfrm>
+          <a:prstGeom prst="line">
+            <a:avLst/>
+          </a:prstGeom>
+          <a:ln w="12700" cap="rnd">
+            <a:solidFill>
+              <a:schemeClr val="accent2">
+                <a:lumMod val="75000"/>
+              </a:schemeClr>
+            </a:solidFill>
+            <a:prstDash val="sysDash"/>
+            <a:round/>
+          </a:ln>
+        </p:spPr>
+        <p:style>
+          <a:lnRef idx="2">
+            <a:schemeClr val="accent1"/>
+          </a:lnRef>
+          <a:fillRef idx="0">
+            <a:schemeClr val="accent1"/>
+          </a:fillRef>
+          <a:effectRef idx="1">
+            <a:schemeClr val="accent1"/>
+          </a:effectRef>
+          <a:fontRef idx="minor">
+            <a:schemeClr val="tx1"/>
+          </a:fontRef>
+        </p:style>
+      </p:cxnSp>
+      <p:cxnSp>
+        <p:nvCxnSpPr>
+          <p:cNvPr id="5" name="Gerade Verbindung mit Pfeil 4">
+            <a:extLst>
+              <a:ext uri="{FF2B5EF4-FFF2-40B4-BE49-F238E27FC236}">
+                <a16:creationId xmlns:a16="http://schemas.microsoft.com/office/drawing/2014/main" id="{0FAA555A-4E85-C572-BE97-09867CDEE58F}"/>
+              </a:ext>
+            </a:extLst>
+          </p:cNvPr>
+          <p:cNvCxnSpPr/>
+          <p:nvPr/>
+        </p:nvCxnSpPr>
+        <p:spPr>
+          <a:xfrm flipV="1">
+            <a:off x="888435" y="851770"/>
+            <a:ext cx="0" cy="1706671"/>
+          </a:xfrm>
+          <a:prstGeom prst="straightConnector1">
+            <a:avLst/>
+          </a:prstGeom>
+          <a:ln w="15875" cap="rnd">
+            <a:solidFill>
+              <a:schemeClr val="tx1"/>
+            </a:solidFill>
+            <a:round/>
+            <a:tailEnd type="triangle"/>
+          </a:ln>
+        </p:spPr>
+        <p:style>
+          <a:lnRef idx="2">
+            <a:schemeClr val="accent1"/>
+          </a:lnRef>
+          <a:fillRef idx="0">
+            <a:schemeClr val="accent1"/>
+          </a:fillRef>
+          <a:effectRef idx="1">
+            <a:schemeClr val="accent1"/>
+          </a:effectRef>
+          <a:fontRef idx="minor">
+            <a:schemeClr val="tx1"/>
+          </a:fontRef>
+        </p:style>
+      </p:cxnSp>
+      <p:sp>
+        <p:nvSpPr>
+          <p:cNvPr id="8" name="Textfeld 7">
+            <a:extLst>
+              <a:ext uri="{FF2B5EF4-FFF2-40B4-BE49-F238E27FC236}">
+                <a16:creationId xmlns:a16="http://schemas.microsoft.com/office/drawing/2014/main" id="{98BF43D2-163A-E046-5ACE-5728381A1227}"/>
+              </a:ext>
+            </a:extLst>
+          </p:cNvPr>
+          <p:cNvSpPr txBox="1"/>
+          <p:nvPr/>
+        </p:nvSpPr>
+        <p:spPr>
+          <a:xfrm>
+            <a:off x="836113" y="757380"/>
+            <a:ext cx="450936" cy="307777"/>
+          </a:xfrm>
+          <a:prstGeom prst="rect">
+            <a:avLst/>
+          </a:prstGeom>
+          <a:noFill/>
+        </p:spPr>
+        <p:txBody>
+          <a:bodyPr wrap="square" rtlCol="0" anchor="ctr">
+            <a:spAutoFit/>
+          </a:bodyPr>
+          <a:lstStyle/>
+          <a:p>
+            <a:pPr algn="ctr"/>
+            <a:r>
+              <a:rPr lang="de-DE" sz="1400" i="1" dirty="0">
+                <a:latin typeface="Latin Modern Math" panose="02000503000000000000" pitchFamily="50" charset="0"/>
+                <a:ea typeface="Latin Modern Math" panose="02000503000000000000" pitchFamily="50" charset="0"/>
+                <a:cs typeface="CMU Serif" panose="02000603000000000000" pitchFamily="2" charset="0"/>
+              </a:rPr>
+              <a:t>χ</a:t>
+            </a:r>
+          </a:p>
+        </p:txBody>
+      </p:sp>
+      <p:sp>
+        <p:nvSpPr>
+          <p:cNvPr id="9" name="Textfeld 8">
+            <a:extLst>
+              <a:ext uri="{FF2B5EF4-FFF2-40B4-BE49-F238E27FC236}">
+                <a16:creationId xmlns:a16="http://schemas.microsoft.com/office/drawing/2014/main" id="{429D3C29-FB50-02F5-367F-1B4E6109C580}"/>
+              </a:ext>
+            </a:extLst>
+          </p:cNvPr>
+          <p:cNvSpPr txBox="1"/>
+          <p:nvPr/>
+        </p:nvSpPr>
+        <p:spPr>
+          <a:xfrm>
+            <a:off x="2507292" y="2406636"/>
+            <a:ext cx="450936" cy="307777"/>
+          </a:xfrm>
+          <a:prstGeom prst="rect">
+            <a:avLst/>
+          </a:prstGeom>
+          <a:noFill/>
+        </p:spPr>
+        <p:txBody>
+          <a:bodyPr wrap="square" rtlCol="0" anchor="ctr">
+            <a:spAutoFit/>
+          </a:bodyPr>
+          <a:lstStyle/>
+          <a:p>
+            <a:pPr algn="ctr"/>
+            <a:r>
+              <a:rPr lang="de-DE" sz="1400" i="1" dirty="0">
+                <a:latin typeface="CMU Serif" panose="02000603000000000000" pitchFamily="2" charset="0"/>
+                <a:ea typeface="CMU Serif" panose="02000603000000000000" pitchFamily="2" charset="0"/>
+                <a:cs typeface="CMU Serif" panose="02000603000000000000" pitchFamily="2" charset="0"/>
+              </a:rPr>
+              <a:t>v</a:t>
+            </a:r>
+          </a:p>
+        </p:txBody>
+      </p:sp>
+      <p:sp>
+        <p:nvSpPr>
+          <p:cNvPr id="10" name="Freihandform: Form 9">
+            <a:extLst>
+              <a:ext uri="{FF2B5EF4-FFF2-40B4-BE49-F238E27FC236}">
+                <a16:creationId xmlns:a16="http://schemas.microsoft.com/office/drawing/2014/main" id="{3DD8C586-4BE1-3355-6B9D-1A55021D8279}"/>
+              </a:ext>
+            </a:extLst>
+          </p:cNvPr>
+          <p:cNvSpPr/>
+          <p:nvPr/>
+        </p:nvSpPr>
+        <p:spPr>
+          <a:xfrm>
+            <a:off x="1249472" y="1121080"/>
+            <a:ext cx="980161" cy="886216"/>
+          </a:xfrm>
+          <a:custGeom>
+            <a:avLst/>
+            <a:gdLst>
+              <a:gd name="csX0" fmla="*/ 0 w 980161"/>
+              <a:gd name="csY0" fmla="*/ 40710 h 1029878"/>
+              <a:gd name="csX1" fmla="*/ 244257 w 980161"/>
+              <a:gd name="csY1" fmla="*/ 939452 h 1029878"/>
+              <a:gd name="csX2" fmla="*/ 604381 w 980161"/>
+              <a:gd name="csY2" fmla="*/ 892479 h 1029878"/>
+              <a:gd name="csX3" fmla="*/ 980161 w 980161"/>
+              <a:gd name="csY3" fmla="*/ 0 h 1029878"/>
+            </a:gdLst>
+            <a:ahLst/>
+            <a:cxnLst>
+              <a:cxn ang="0">
+                <a:pos x="csX0" y="csY0"/>
+              </a:cxn>
+              <a:cxn ang="0">
+                <a:pos x="csX1" y="csY1"/>
+              </a:cxn>
+              <a:cxn ang="0">
+                <a:pos x="csX2" y="csY2"/>
+              </a:cxn>
+              <a:cxn ang="0">
+                <a:pos x="csX3" y="csY3"/>
+              </a:cxn>
+            </a:cxnLst>
+            <a:rect l="l" t="t" r="r" b="b"/>
+            <a:pathLst>
+              <a:path w="980161" h="1029878">
+                <a:moveTo>
+                  <a:pt x="0" y="40710"/>
+                </a:moveTo>
+                <a:cubicBezTo>
+                  <a:pt x="71763" y="419100"/>
+                  <a:pt x="143527" y="797490"/>
+                  <a:pt x="244257" y="939452"/>
+                </a:cubicBezTo>
+                <a:cubicBezTo>
+                  <a:pt x="344987" y="1081414"/>
+                  <a:pt x="481730" y="1049054"/>
+                  <a:pt x="604381" y="892479"/>
+                </a:cubicBezTo>
+                <a:cubicBezTo>
+                  <a:pt x="727032" y="735904"/>
+                  <a:pt x="853596" y="367952"/>
+                  <a:pt x="980161" y="0"/>
+                </a:cubicBezTo>
+              </a:path>
+            </a:pathLst>
+          </a:custGeom>
+          <a:noFill/>
+          <a:ln w="15875" cap="rnd">
+            <a:solidFill>
+              <a:schemeClr val="tx1"/>
+            </a:solidFill>
+            <a:round/>
+          </a:ln>
+        </p:spPr>
+        <p:style>
+          <a:lnRef idx="2">
+            <a:schemeClr val="accent1">
+              <a:shade val="15000"/>
+            </a:schemeClr>
+          </a:lnRef>
+          <a:fillRef idx="1">
+            <a:schemeClr val="accent1"/>
+          </a:fillRef>
+          <a:effectRef idx="0">
+            <a:schemeClr val="accent1"/>
+          </a:effectRef>
+          <a:fontRef idx="minor">
+            <a:schemeClr val="lt1"/>
+          </a:fontRef>
+        </p:style>
+        <p:txBody>
+          <a:bodyPr rtlCol="0" anchor="ctr"/>
+          <a:lstStyle/>
+          <a:p>
+            <a:pPr algn="ctr"/>
+            <a:endParaRPr lang="de-DE"/>
+          </a:p>
+        </p:txBody>
+      </p:sp>
+      <p:sp>
+        <p:nvSpPr>
+          <p:cNvPr id="16" name="Ellipse 15">
+            <a:extLst>
+              <a:ext uri="{FF2B5EF4-FFF2-40B4-BE49-F238E27FC236}">
+                <a16:creationId xmlns:a16="http://schemas.microsoft.com/office/drawing/2014/main" id="{E996857E-A6BB-F900-D30B-E1F7FB182328}"/>
+              </a:ext>
+            </a:extLst>
+          </p:cNvPr>
+          <p:cNvSpPr/>
+          <p:nvPr/>
+        </p:nvSpPr>
+        <p:spPr>
+          <a:xfrm>
+            <a:off x="1749886" y="1937411"/>
+            <a:ext cx="45719" cy="45719"/>
+          </a:xfrm>
+          <a:prstGeom prst="ellipse">
+            <a:avLst/>
+          </a:prstGeom>
+          <a:solidFill>
+            <a:schemeClr val="accent1"/>
+          </a:solidFill>
+          <a:ln>
+            <a:noFill/>
+          </a:ln>
+        </p:spPr>
+        <p:style>
+          <a:lnRef idx="2">
+            <a:schemeClr val="accent1">
+              <a:shade val="15000"/>
+            </a:schemeClr>
+          </a:lnRef>
+          <a:fillRef idx="1">
+            <a:schemeClr val="accent1"/>
+          </a:fillRef>
+          <a:effectRef idx="0">
+            <a:schemeClr val="accent1"/>
+          </a:effectRef>
+          <a:fontRef idx="minor">
+            <a:schemeClr val="lt1"/>
+          </a:fontRef>
+        </p:style>
+        <p:txBody>
+          <a:bodyPr rtlCol="0" anchor="ctr"/>
+          <a:lstStyle/>
+          <a:p>
+            <a:pPr algn="ctr"/>
+            <a:endParaRPr lang="de-DE"/>
+          </a:p>
+        </p:txBody>
+      </p:sp>
+      <p:sp>
+        <p:nvSpPr>
+          <p:cNvPr id="17" name="Ellipse 16">
+            <a:extLst>
+              <a:ext uri="{FF2B5EF4-FFF2-40B4-BE49-F238E27FC236}">
+                <a16:creationId xmlns:a16="http://schemas.microsoft.com/office/drawing/2014/main" id="{9F42A8E9-4357-0D33-77AC-C9B620F56EED}"/>
+              </a:ext>
+            </a:extLst>
+          </p:cNvPr>
+          <p:cNvSpPr/>
+          <p:nvPr/>
+        </p:nvSpPr>
+        <p:spPr>
+          <a:xfrm>
+            <a:off x="1618441" y="1985036"/>
+            <a:ext cx="45719" cy="45719"/>
+          </a:xfrm>
+          <a:prstGeom prst="ellipse">
+            <a:avLst/>
+          </a:prstGeom>
+          <a:solidFill>
+            <a:schemeClr val="accent2">
+              <a:lumMod val="75000"/>
+            </a:schemeClr>
+          </a:solidFill>
+          <a:ln>
+            <a:noFill/>
+          </a:ln>
+        </p:spPr>
+        <p:style>
+          <a:lnRef idx="2">
+            <a:schemeClr val="accent1">
+              <a:shade val="15000"/>
+            </a:schemeClr>
+          </a:lnRef>
+          <a:fillRef idx="1">
+            <a:schemeClr val="accent1"/>
+          </a:fillRef>
+          <a:effectRef idx="0">
+            <a:schemeClr val="accent1"/>
+          </a:effectRef>
+          <a:fontRef idx="minor">
+            <a:schemeClr val="lt1"/>
+          </a:fontRef>
+        </p:style>
+        <p:txBody>
+          <a:bodyPr rtlCol="0" anchor="ctr"/>
+          <a:lstStyle/>
+          <a:p>
+            <a:pPr algn="ctr"/>
+            <a:endParaRPr lang="de-DE"/>
+          </a:p>
+        </p:txBody>
+      </p:sp>
+      <p:cxnSp>
+        <p:nvCxnSpPr>
+          <p:cNvPr id="18" name="Gerader Verbinder 17">
+            <a:extLst>
+              <a:ext uri="{FF2B5EF4-FFF2-40B4-BE49-F238E27FC236}">
+                <a16:creationId xmlns:a16="http://schemas.microsoft.com/office/drawing/2014/main" id="{07676432-51C0-EFB0-A632-51B22CEA8103}"/>
+              </a:ext>
+            </a:extLst>
+          </p:cNvPr>
+          <p:cNvCxnSpPr>
+            <a:cxnSpLocks/>
+            <a:endCxn id="17" idx="4"/>
+          </p:cNvCxnSpPr>
+          <p:nvPr/>
+        </p:nvCxnSpPr>
+        <p:spPr>
+          <a:xfrm flipV="1">
+            <a:off x="1641300" y="2030755"/>
+            <a:ext cx="1" cy="527686"/>
+          </a:xfrm>
+          <a:prstGeom prst="line">
+            <a:avLst/>
+          </a:prstGeom>
+          <a:ln w="12700" cap="rnd">
+            <a:solidFill>
+              <a:schemeClr val="accent2">
+                <a:lumMod val="75000"/>
+              </a:schemeClr>
+            </a:solidFill>
+            <a:prstDash val="solid"/>
+            <a:round/>
+            <a:headEnd type="triangle" w="sm" len="sm"/>
+          </a:ln>
+        </p:spPr>
+        <p:style>
+          <a:lnRef idx="2">
+            <a:schemeClr val="accent1"/>
+          </a:lnRef>
+          <a:fillRef idx="0">
+            <a:schemeClr val="accent1"/>
+          </a:fillRef>
+          <a:effectRef idx="1">
+            <a:schemeClr val="accent1"/>
+          </a:effectRef>
+          <a:fontRef idx="minor">
+            <a:schemeClr val="tx1"/>
+          </a:fontRef>
+        </p:style>
+      </p:cxnSp>
+      <p:cxnSp>
+        <p:nvCxnSpPr>
+          <p:cNvPr id="21" name="Gerader Verbinder 20">
+            <a:extLst>
+              <a:ext uri="{FF2B5EF4-FFF2-40B4-BE49-F238E27FC236}">
+                <a16:creationId xmlns:a16="http://schemas.microsoft.com/office/drawing/2014/main" id="{5AC0AC09-61FC-6919-56F7-26919F532C67}"/>
+              </a:ext>
+            </a:extLst>
+          </p:cNvPr>
+          <p:cNvCxnSpPr>
+            <a:cxnSpLocks/>
+            <a:endCxn id="16" idx="4"/>
+          </p:cNvCxnSpPr>
+          <p:nvPr/>
+        </p:nvCxnSpPr>
+        <p:spPr>
+          <a:xfrm flipV="1">
+            <a:off x="1772745" y="1983130"/>
+            <a:ext cx="1" cy="575311"/>
+          </a:xfrm>
+          <a:prstGeom prst="line">
+            <a:avLst/>
+          </a:prstGeom>
+          <a:ln w="12700" cap="rnd">
+            <a:solidFill>
+              <a:schemeClr val="accent1"/>
+            </a:solidFill>
+            <a:prstDash val="solid"/>
+            <a:round/>
+            <a:headEnd type="triangle" w="sm" len="sm"/>
+          </a:ln>
+        </p:spPr>
+        <p:style>
+          <a:lnRef idx="2">
+            <a:schemeClr val="accent1"/>
+          </a:lnRef>
+          <a:fillRef idx="0">
+            <a:schemeClr val="accent1"/>
+          </a:fillRef>
+          <a:effectRef idx="1">
+            <a:schemeClr val="accent1"/>
+          </a:effectRef>
+          <a:fontRef idx="minor">
+            <a:schemeClr val="tx1"/>
+          </a:fontRef>
+        </p:style>
+      </p:cxnSp>
+      <p:cxnSp>
+        <p:nvCxnSpPr>
+          <p:cNvPr id="6" name="Gerade Verbindung mit Pfeil 5">
+            <a:extLst>
+              <a:ext uri="{FF2B5EF4-FFF2-40B4-BE49-F238E27FC236}">
+                <a16:creationId xmlns:a16="http://schemas.microsoft.com/office/drawing/2014/main" id="{9D82C0B4-EF39-2168-2AD7-6FE8F444F077}"/>
+              </a:ext>
+            </a:extLst>
+          </p:cNvPr>
+          <p:cNvCxnSpPr>
+            <a:cxnSpLocks/>
+          </p:cNvCxnSpPr>
+          <p:nvPr/>
+        </p:nvCxnSpPr>
+        <p:spPr>
+          <a:xfrm>
+            <a:off x="888435" y="2560528"/>
+            <a:ext cx="1748424" cy="0"/>
+          </a:xfrm>
+          <a:prstGeom prst="straightConnector1">
+            <a:avLst/>
+          </a:prstGeom>
+          <a:ln w="15875" cap="rnd">
+            <a:solidFill>
+              <a:schemeClr val="tx1"/>
+            </a:solidFill>
+            <a:round/>
+            <a:tailEnd type="triangle"/>
+          </a:ln>
+        </p:spPr>
+        <p:style>
+          <a:lnRef idx="2">
+            <a:schemeClr val="accent1"/>
+          </a:lnRef>
+          <a:fillRef idx="0">
+            <a:schemeClr val="accent1"/>
+          </a:fillRef>
+          <a:effectRef idx="1">
+            <a:schemeClr val="accent1"/>
+          </a:effectRef>
+          <a:fontRef idx="minor">
+            <a:schemeClr val="tx1"/>
+          </a:fontRef>
+        </p:style>
+      </p:cxnSp>
+      <p:sp>
+        <p:nvSpPr>
+          <p:cNvPr id="25" name="Textfeld 24">
+            <a:extLst>
+              <a:ext uri="{FF2B5EF4-FFF2-40B4-BE49-F238E27FC236}">
+                <a16:creationId xmlns:a16="http://schemas.microsoft.com/office/drawing/2014/main" id="{B116B872-F152-3DB2-6777-229C62D5CB3A}"/>
+              </a:ext>
+            </a:extLst>
+          </p:cNvPr>
+          <p:cNvSpPr txBox="1"/>
+          <p:nvPr/>
+        </p:nvSpPr>
+        <p:spPr>
+          <a:xfrm>
+            <a:off x="1070514" y="2506210"/>
+            <a:ext cx="752301" cy="307777"/>
+          </a:xfrm>
+          <a:prstGeom prst="rect">
+            <a:avLst/>
+          </a:prstGeom>
+          <a:noFill/>
+        </p:spPr>
+        <p:txBody>
+          <a:bodyPr wrap="square" rtlCol="0" anchor="ctr">
+            <a:spAutoFit/>
+          </a:bodyPr>
+          <a:lstStyle/>
+          <a:p>
+            <a:pPr algn="ctr"/>
+            <a:r>
+              <a:rPr lang="de-DE" sz="1400" i="1" dirty="0" err="1">
+                <a:solidFill>
+                  <a:schemeClr val="accent2">
+                    <a:lumMod val="75000"/>
+                  </a:schemeClr>
+                </a:solidFill>
+                <a:latin typeface="CMU Serif" panose="02000603000000000000" pitchFamily="2" charset="0"/>
+                <a:ea typeface="CMU Serif" panose="02000603000000000000" pitchFamily="2" charset="0"/>
+                <a:cs typeface="CMU Serif" panose="02000603000000000000" pitchFamily="2" charset="0"/>
+              </a:rPr>
+              <a:t>v</a:t>
+            </a:r>
+            <a:r>
+              <a:rPr lang="de-DE" sz="1400" i="1" baseline="-25000" dirty="0" err="1">
+                <a:solidFill>
+                  <a:schemeClr val="accent2">
+                    <a:lumMod val="75000"/>
+                  </a:schemeClr>
+                </a:solidFill>
+                <a:latin typeface="CMU Serif" panose="02000603000000000000" pitchFamily="2" charset="0"/>
+                <a:ea typeface="CMU Serif" panose="02000603000000000000" pitchFamily="2" charset="0"/>
+                <a:cs typeface="CMU Serif" panose="02000603000000000000" pitchFamily="2" charset="0"/>
+              </a:rPr>
+              <a:t>T</a:t>
+            </a:r>
+            <a:r>
+              <a:rPr lang="de-DE" sz="500" baseline="-25000" dirty="0">
+                <a:solidFill>
+                  <a:schemeClr val="accent2">
+                    <a:lumMod val="75000"/>
+                  </a:schemeClr>
+                </a:solidFill>
+                <a:latin typeface="CMU Serif" panose="02000603000000000000" pitchFamily="2" charset="0"/>
+                <a:ea typeface="CMU Serif" panose="02000603000000000000" pitchFamily="2" charset="0"/>
+                <a:cs typeface="CMU Serif" panose="02000603000000000000" pitchFamily="2" charset="0"/>
+              </a:rPr>
+              <a:t> </a:t>
+            </a:r>
+            <a:r>
+              <a:rPr lang="de-DE" sz="1400" baseline="-25000" dirty="0" err="1">
+                <a:solidFill>
+                  <a:schemeClr val="accent2">
+                    <a:lumMod val="75000"/>
+                  </a:schemeClr>
+                </a:solidFill>
+                <a:latin typeface="CMU Serif" panose="02000603000000000000" pitchFamily="2" charset="0"/>
+                <a:ea typeface="CMU Serif" panose="02000603000000000000" pitchFamily="2" charset="0"/>
+                <a:cs typeface="CMU Serif" panose="02000603000000000000" pitchFamily="2" charset="0"/>
+              </a:rPr>
+              <a:t>max</a:t>
+            </a:r>
+            <a:endParaRPr lang="de-DE" sz="1400" baseline="-25000" dirty="0">
+              <a:solidFill>
+                <a:schemeClr val="accent2">
+                  <a:lumMod val="75000"/>
+                </a:schemeClr>
+              </a:solidFill>
+              <a:latin typeface="CMU Serif" panose="02000603000000000000" pitchFamily="2" charset="0"/>
+              <a:ea typeface="CMU Serif" panose="02000603000000000000" pitchFamily="2" charset="0"/>
+              <a:cs typeface="CMU Serif" panose="02000603000000000000" pitchFamily="2" charset="0"/>
+            </a:endParaRPr>
+          </a:p>
+        </p:txBody>
+      </p:sp>
+      <p:sp>
+        <p:nvSpPr>
+          <p:cNvPr id="26" name="Textfeld 25">
+            <a:extLst>
+              <a:ext uri="{FF2B5EF4-FFF2-40B4-BE49-F238E27FC236}">
+                <a16:creationId xmlns:a16="http://schemas.microsoft.com/office/drawing/2014/main" id="{E749AB0C-B985-4164-DFCA-8B87FD599201}"/>
+              </a:ext>
+            </a:extLst>
+          </p:cNvPr>
+          <p:cNvSpPr txBox="1"/>
+          <p:nvPr/>
+        </p:nvSpPr>
+        <p:spPr>
+          <a:xfrm>
+            <a:off x="1609686" y="2503670"/>
+            <a:ext cx="752301" cy="307777"/>
+          </a:xfrm>
+          <a:prstGeom prst="rect">
+            <a:avLst/>
+          </a:prstGeom>
+          <a:noFill/>
+        </p:spPr>
+        <p:txBody>
+          <a:bodyPr wrap="square" rtlCol="0" anchor="ctr">
+            <a:spAutoFit/>
+          </a:bodyPr>
+          <a:lstStyle/>
+          <a:p>
+            <a:pPr algn="ctr"/>
+            <a:r>
+              <a:rPr lang="de-DE" sz="1400" i="1" dirty="0" err="1">
+                <a:solidFill>
+                  <a:schemeClr val="accent1"/>
+                </a:solidFill>
+                <a:latin typeface="CMU Serif" panose="02000603000000000000" pitchFamily="2" charset="0"/>
+                <a:ea typeface="CMU Serif" panose="02000603000000000000" pitchFamily="2" charset="0"/>
+                <a:cs typeface="CMU Serif" panose="02000603000000000000" pitchFamily="2" charset="0"/>
+              </a:rPr>
+              <a:t>v</a:t>
+            </a:r>
+            <a:r>
+              <a:rPr lang="de-DE" sz="1400" i="1" baseline="-25000" dirty="0" err="1">
+                <a:solidFill>
+                  <a:schemeClr val="accent1"/>
+                </a:solidFill>
+                <a:latin typeface="CMU Serif" panose="02000603000000000000" pitchFamily="2" charset="0"/>
+                <a:ea typeface="CMU Serif" panose="02000603000000000000" pitchFamily="2" charset="0"/>
+                <a:cs typeface="CMU Serif" panose="02000603000000000000" pitchFamily="2" charset="0"/>
+              </a:rPr>
+              <a:t>R</a:t>
+            </a:r>
+            <a:r>
+              <a:rPr lang="de-DE" sz="500" baseline="-25000" dirty="0">
+                <a:solidFill>
+                  <a:schemeClr val="accent1"/>
+                </a:solidFill>
+                <a:latin typeface="CMU Serif" panose="02000603000000000000" pitchFamily="2" charset="0"/>
+                <a:ea typeface="CMU Serif" panose="02000603000000000000" pitchFamily="2" charset="0"/>
+                <a:cs typeface="CMU Serif" panose="02000603000000000000" pitchFamily="2" charset="0"/>
+              </a:rPr>
+              <a:t> </a:t>
+            </a:r>
+            <a:r>
+              <a:rPr lang="de-DE" sz="1400" baseline="-25000" dirty="0" err="1">
+                <a:solidFill>
+                  <a:schemeClr val="accent1"/>
+                </a:solidFill>
+                <a:latin typeface="CMU Serif" panose="02000603000000000000" pitchFamily="2" charset="0"/>
+                <a:ea typeface="CMU Serif" panose="02000603000000000000" pitchFamily="2" charset="0"/>
+                <a:cs typeface="CMU Serif" panose="02000603000000000000" pitchFamily="2" charset="0"/>
+              </a:rPr>
+              <a:t>max</a:t>
+            </a:r>
+            <a:endParaRPr lang="de-DE" sz="1400" baseline="-25000" dirty="0">
+              <a:solidFill>
+                <a:schemeClr val="accent1"/>
+              </a:solidFill>
+              <a:latin typeface="CMU Serif" panose="02000603000000000000" pitchFamily="2" charset="0"/>
+              <a:ea typeface="CMU Serif" panose="02000603000000000000" pitchFamily="2" charset="0"/>
+              <a:cs typeface="CMU Serif" panose="02000603000000000000" pitchFamily="2" charset="0"/>
+            </a:endParaRPr>
+          </a:p>
+        </p:txBody>
+      </p:sp>
+    </p:spTree>
+    <p:extLst>
+      <p:ext uri="{BB962C8B-B14F-4D97-AF65-F5344CB8AC3E}">
+        <p14:creationId xmlns:p14="http://schemas.microsoft.com/office/powerpoint/2010/main" val="4010601396"/>
       </p:ext>
     </p:extLst>
   </p:cSld>

</xml_diff>